<commit_message>
Update report and presentation for live deployment and officer sign-up
</commit_message>
<xml_diff>
--- a/project_documentation/NEXORA_Project_Presentation.pptx
+++ b/project_documentation/NEXORA_Project_Presentation.pptx
@@ -120,21 +120,21 @@
   <p:extLst>
     <p:ext uri="{521415D9-36F7-43E2-AB2F-B90AF26B5E84}">
       <p14:sectionLst xmlns:p14="http://schemas.microsoft.com/office/powerpoint/2010/main">
-        <p14:section name="Introduction" id="{63489272-9f69-d935-effb-711a2f4fb5d4}">
+        <p14:section name="Introduction" id="{b11aeb0b-f807-7e48-2c3f-35a7af86a701}">
           <p14:sldIdLst>
             <p14:sldId id="256"/>
             <p14:sldId id="257"/>
             <p14:sldId id="258"/>
           </p14:sldIdLst>
         </p14:section>
-        <p14:section name="Design" id="{fd89d150-46f0-79f4-92d8-ccd3629c0fb9}">
+        <p14:section name="Design" id="{57e3bef6-9b41-40fc-5a84-c07b3d54310f}">
           <p14:sldIdLst>
             <p14:sldId id="259"/>
             <p14:sldId id="260"/>
             <p14:sldId id="261"/>
           </p14:sldIdLst>
         </p14:section>
-        <p14:section name="Features" id="{49d178b4-3efc-ae78-7469-79ac06e362c6}">
+        <p14:section name="Features" id="{31f1297f-7f87-2010-c703-8009309a0099}">
           <p14:sldIdLst>
             <p14:sldId id="262"/>
             <p14:sldId id="263"/>
@@ -143,7 +143,7 @@
             <p14:sldId id="266"/>
           </p14:sldIdLst>
         </p14:section>
-        <p14:section name="Results" id="{fa2a65f3-952b-00f5-46bc-e06f9b484a80}">
+        <p14:section name="Results" id="{b6dd1d7e-8eae-0b18-ce5a-bb7b2fcc879d}">
           <p14:sldIdLst>
             <p14:sldId id="267"/>
             <p14:sldId id="268"/>
@@ -3963,7 +3963,7 @@
       </p:sp>
       <p:pic>
         <p:nvPicPr>
-          <p:cNvPr id="15" name="shot Drive stage schedules" descr="Drive stage schedules">    </p:cNvPr>
+          <p:cNvPr id="15" name="shot Live on a real phone" descr="Live on a real phone">    </p:cNvPr>
           <p:cNvPicPr>
             <a:picLocks noChangeAspect="1"/>
           </p:cNvPicPr>
@@ -3987,7 +3987,7 @@
       </p:pic>
       <p:sp>
         <p:nvSpPr>
-          <p:cNvPr id="16" name="shot Drive stage schedules frame"/>
+          <p:cNvPr id="16" name="shot Live on a real phone frame"/>
           <p:cNvSpPr/>
           <p:nvPr/>
         </p:nvSpPr>
@@ -4039,7 +4039,7 @@
                   <a:schemeClr val="accent6"/>
                 </a:solidFill>
               </a:rPr>
-              <a:t>Drive stage schedules</a:t>
+              <a:t>Live on a real phone</a:t>
             </a:r>
             <a:endParaRPr lang="en-US" sz="1100" dirty="0"/>
           </a:p>
@@ -4210,7 +4210,7 @@
                   <a:srgbClr val="3B4BDB"/>
                 </a:solidFill>
               </a:rPr>
-              <a:t>64 / 64</a:t>
+              <a:t>65 / 65</a:t>
             </a:r>
             <a:endParaRPr lang="en-US" sz="4000" dirty="0"/>
           </a:p>
@@ -4408,7 +4408,7 @@
                   <a:srgbClr val="B50246"/>
                 </a:solidFill>
               </a:rPr>
-              <a:t>47 / 47</a:t>
+              <a:t>48 / 48</a:t>
             </a:r>
             <a:endParaRPr lang="en-US" sz="4000" dirty="0"/>
           </a:p>
@@ -4673,7 +4673,7 @@
                   <a:schemeClr val="tx1"/>
                 </a:solidFill>
               </a:rPr>
-              <a:t>Rules: role escalation, verification lock, duplicates, deadlines, outcomes</a:t>
+              <a:t>Rules: role locked after sign-up, verification lock, duplicates, deadlines, outcomes</a:t>
             </a:r>
             <a:endParaRPr lang="en-US" sz="1300" dirty="0"/>
           </a:p>
@@ -4727,7 +4727,7 @@
                   <a:schemeClr val="accent2"/>
                 </a:solidFill>
               </a:rPr>
-              <a:t>Manual (emulator + Firebase Emulator Suite)</a:t>
+              <a:t>Live: officer on emulator, student on phone</a:t>
             </a:r>
             <a:endParaRPr lang="en-US" sz="1800" dirty="0"/>
           </a:p>
@@ -4767,7 +4767,7 @@
                   <a:schemeClr val="tx1"/>
                 </a:solidFill>
               </a:rPr>
-              <a:t>Login errors and role-based routing</a:t>
+              <a:t>Published drive → "New drive" notification on the phone</a:t>
             </a:r>
             <a:endParaRPr lang="en-US" sz="1300" dirty="0"/>
           </a:p>
@@ -4785,7 +4785,7 @@
                   <a:schemeClr val="tx1"/>
                 </a:solidFill>
               </a:rPr>
-              <a:t>Verification unlocks eligibility; officer-created drive reaches students</a:t>
+              <a:t>Officer verifies → phone shows Eligible, 65% match, Apply enabled</a:t>
             </a:r>
             <a:endParaRPr lang="en-US" sz="1300" dirty="0"/>
           </a:p>
@@ -4803,7 +4803,7 @@
                   <a:schemeClr val="tx1"/>
                 </a:solidFill>
               </a:rPr>
-              <a:t>Application accepted, duplicate blocked, advance updates timeline + notification</a:t>
+              <a:t>Student applies → officer dashboard updates instantly</a:t>
             </a:r>
             <a:endParaRPr lang="en-US" sz="1300" dirty="0"/>
           </a:p>
@@ -4821,7 +4821,7 @@
                   <a:schemeClr val="tx1"/>
                 </a:solidFill>
               </a:rPr>
-              <a:t>Offline activity synced exactly once after reconnecting</a:t>
+              <a:t>Officer advances → stage notification on the phone</a:t>
             </a:r>
             <a:endParaRPr lang="en-US" sz="1300" dirty="0"/>
           </a:p>
@@ -4839,7 +4839,7 @@
                   <a:schemeClr val="tx1"/>
                 </a:solidFill>
               </a:rPr>
-              <a:t>Analytics and insights match hand-calculated seed values</a:t>
+              <a:t>Announcement via background sync; no errors on either device</a:t>
             </a:r>
             <a:endParaRPr lang="en-US" sz="1300" dirty="0"/>
           </a:p>
@@ -5305,7 +5305,7 @@
                   <a:schemeClr val="tx1"/>
                 </a:solidFill>
               </a:rPr>
-              <a:t>Officer-configurable match weights and readiness targets</a:t>
+              <a:t>Officer approval step instead of open officer sign-up</a:t>
             </a:r>
             <a:endParaRPr lang="en-US" sz="1700" dirty="0"/>
           </a:p>
@@ -7950,7 +7950,7 @@
                   <a:schemeClr val="accent6"/>
                 </a:solidFill>
               </a:rPr>
-              <a:t>Email and password; Emulator Suite in debug</a:t>
+              <a:t>Email and password; live project nexora-a014b</a:t>
             </a:r>
             <a:endParaRPr lang="en-US" sz="1300" dirty="0"/>
           </a:p>
@@ -10321,7 +10321,7 @@
                   <a:schemeClr val="tx1"/>
                 </a:solidFill>
               </a:rPr>
-              <a:t>Onboarding, registration (always STUDENT), login, password reset</a:t>
+              <a:t>Onboarding, sign-up as Student or Placement officer, login, password reset</a:t>
             </a:r>
             <a:endParaRPr lang="en-US" sz="1500" dirty="0"/>
           </a:p>
@@ -11081,7 +11081,7 @@
                   <a:schemeClr val="tx1"/>
                 </a:solidFill>
               </a:rPr>
-              <a:t>Separate role-based navigation; officer accounts provisioned only by the admin seed script</a:t>
+              <a:t>Officer account created in the app (role fixed at sign-up); separate role-based navigation</a:t>
             </a:r>
             <a:endParaRPr lang="en-US" sz="1500" dirty="0"/>
           </a:p>
@@ -11117,7 +11117,7 @@
                   <a:schemeClr val="tx1"/>
                 </a:solidFill>
               </a:rPr>
-              <a:t>Companies and drives: criteria, skills, prep focus, deadline, ordered stages; draft, publish, close</a:t>
+              <a:t>Companies and drives: criteria, skills, prep focus, deadline, stages; publishing notifies every student</a:t>
             </a:r>
             <a:endParaRPr lang="en-US" sz="1500" dirty="0"/>
           </a:p>

</xml_diff>